<commit_message>
Add intent retrieval evaluation with reviewed positives and ULIP-2 query drafts
</commit_message>
<xml_diff>
--- a/notion_paper/MetaFind_Table1_Stage2_含講稿.pptx
+++ b/notion_paper/MetaFind_Table1_Stage2_含講稿.pptx
@@ -546,7 +546,7 @@
                 <a:ea typeface="Noto Sans CJK TC"/>
                 <a:cs typeface="Noto Sans CJK TC"/>
               </a:rPr>
-              <a:t>今天的報告分成兩部分。第一部分是標註更新：我們如何讓模型從不同角度看同一件三維物件，再把看到的內容整理成一張電腦能讀取的資料卡，以及目前這批工作處理到哪裡。第二部分是評估計畫：資料準備好以後，要用哪些題目比較模型，又怎麼判斷它是否找到了正確資產。大家可以把整個系統想成一座三維物件圖書館。標註是在替每件物件建立目錄卡，訓練是在教模型把不同線索連到同一件物件，評估則是在檢查它能否從候選清單找回指定的那一件。這三件事需要分開看：資料卡成功寫出來，不代表每個描述都完全正確；程式跑得通，也不代表模型已達到論文成績。目前最新完整資料集的正式比較還沒有執行，因此這份報告會清楚區分已觀察到的進度、已完成的小型流程驗證，以及接下來要執行的評估，不把計畫說成結果。</a:t>
+              <a:t>今天的報告分成兩部分。第一部分是標註更新：我們如何讓模型從不同角度看同一件三維物件，再把看到的內容整理成一張電腦能讀取的資料卡，以及目前這批工作處理到哪裡。第二部分是評估計畫：資料準備好以後，要用哪些題目比較模型，又怎麼判斷它是否找到了正確資產。大家可以把整個系統想成一座三維物件圖書館。標註是在替每件物件建立目錄卡，訓練是在教模型把不同線索連到同一件物件，評估則是在檢查它能否從候選清單找到符合需求的物件。這三件事需要分開看：資料卡成功寫出來，不代表每個描述都完全正確；程式跑得通，也不代表模型已達到論文成績。目前最新完整資料集的正式比較還沒有執行，因此這份報告會清楚區分已觀察到的進度、已完成的小型流程驗證，以及接下來要執行的評估，不把計畫說成結果。</a:t>
             </a:r>
           </a:p>
           <a:p/>
@@ -691,7 +691,7 @@
                 <a:ea typeface="Noto Sans CJK TC"/>
                 <a:cs typeface="Noto Sans CJK TC"/>
               </a:rPr>
-              <a:t>第 10 頁｜標註結束後，依序完成六步</a:t>
+              <a:t>第 10 頁｜標註後，補齊資料、模型與需求考卷</a:t>
             </a:r>
           </a:p>
           <a:p>
@@ -718,7 +718,7 @@
                 <a:ea typeface="Noto Sans CJK TC"/>
                 <a:cs typeface="Noto Sans CJK TC"/>
               </a:rPr>
-              <a:t>標註處理完，後面還有六個步驟。先把原始清單、成功資產、真正失敗和已批准的人工排除對清楚，不把失敗假裝成成功，也不任意改掉原本的母體。第二步，把文字和圖片轉成模型能讀的特徵，固定資料切分，再另外執行 G3 資料預檢。第三步進行 Stage 1 物件配對訓練，保存實際權重和選模範圍。第四步，用指定模型建立候選資產向量，經 G4 核驗後發布。第五步備妥場景、節點、關係與場景候選資料，才能進行 Stage 2 訓練，讓模型學習候選物件與房間裡其他家具之間的關係。最後才是今天介紹的四十二組比較，並另行做場景資訊開啟與關閉的診斷。這裡要分清自動流程和人工接續工作：目前 G3 與新的自訂評估沒有接入現有等待鏈，需要另外執行，不能以為標註結束就會自動產生所有結果。場景檢索診斷也不等於完整場景品質研究；完整場景清單、評分提示等協定細節尚未確定，因此不能宣稱論文 Table 2 已經完成。下一次報告應拿固定資料和權重實際產生的證據，逐項交代哪些完成、哪些仍待驗證。</a:t>
+              <a:t>標註完成以後，第一步仍是把成功資料、真正失敗與人工排除分清楚。接著建立文字與圖片特徵，固定資料切分，完成需要的資料預檢。模型部分先訓練 Stage 1，核驗並固定候選向量，再準備房間、節點與關係資料，進行 Stage 2；其中關閉場景資訊的評估列沿用 Stage 1 的候選庫。同時可以提早開始另一條工作：撰寫真實家具需求，取得必要的參考照片或點雲，為每個需求編號。最花判斷的部分，是依每種可見線索，審完固定候選池裡哪些物件能接受。只有這份考卷與答案在模型排名前封存，才進入正式主評估。最後報告 Hit@1、Hit@5、輔助 Recall、每條件題數與候選數，原本同資產辨識的診斷另列。標註佇列結束不會自動替我們寫題或完成人工審核，也不代表新評估已執行。這次回答的是找家具是否合適，沒有因此完成場景品質或論文 Table 2 的驗證。</a:t>
             </a:r>
           </a:p>
           <a:p/>
@@ -732,7 +732,7 @@
                 <a:ea typeface="Noto Sans CJK TC"/>
                 <a:cs typeface="Noto Sans CJK TC"/>
               </a:rPr>
-              <a:t>本頁重點：先固定資料，再訓練、建候選庫，最後另行執行正式評估。</a:t>
+              <a:t>本頁重點：完整題目與正解先封存，模型準備好後再另行執行主評估。</a:t>
             </a:r>
           </a:p>
           <a:p/>
@@ -759,7 +759,7 @@
                 <a:ea typeface="Noto Sans CJK TC"/>
                 <a:cs typeface="Noto Sans CJK TC"/>
               </a:rPr>
-              <a:t>docs/DATA_FLOW.md#L116</a:t>
+              <a:t>docs/INTENT_RETRIEVAL_EVALUATION.md#L261</a:t>
             </a:r>
           </a:p>
           <a:p>
@@ -785,46 +785,7 @@
                 <a:ea typeface="Noto Sans CJK TC"/>
                 <a:cs typeface="Noto Sans CJK TC"/>
               </a:rPr>
-              <a:t>tools/chain_paper_stage1.sh#L128</a:t>
-            </a:r>
-          </a:p>
-          <a:p>
-            <a:r>
-              <a:rPr sz="1200" b="0">
-                <a:solidFill>
-                  <a:srgbClr val="183247"/>
-                </a:solidFill>
-                <a:latin typeface="Noto Sans CJK TC"/>
-                <a:ea typeface="Noto Sans CJK TC"/>
-                <a:cs typeface="Noto Sans CJK TC"/>
-              </a:rPr>
               <a:t>tools/chain_paper_stage2.sh#L41</a:t>
-            </a:r>
-          </a:p>
-          <a:p>
-            <a:r>
-              <a:rPr sz="1200" b="0">
-                <a:solidFill>
-                  <a:srgbClr val="183247"/>
-                </a:solidFill>
-                <a:latin typeface="Noto Sans CJK TC"/>
-                <a:ea typeface="Noto Sans CJK TC"/>
-                <a:cs typeface="Noto Sans CJK TC"/>
-              </a:rPr>
-              <a:t>docs/DATA_FLOW.md#L164</a:t>
-            </a:r>
-          </a:p>
-          <a:p>
-            <a:r>
-              <a:rPr sz="1200" b="0">
-                <a:solidFill>
-                  <a:srgbClr val="183247"/>
-                </a:solidFill>
-                <a:latin typeface="Noto Sans CJK TC"/>
-                <a:ea typeface="Noto Sans CJK TC"/>
-                <a:cs typeface="Noto Sans CJK TC"/>
-              </a:rPr>
-              <a:t>docs/paper/metafind_source/3experiments.tex#L18</a:t>
             </a:r>
           </a:p>
           <a:p>
@@ -1668,7 +1629,7 @@
                 <a:ea typeface="Noto Sans CJK TC"/>
                 <a:cs typeface="Noto Sans CJK TC"/>
               </a:rPr>
-              <a:t>第 06 頁｜同一批題目，比較三種方法</a:t>
+              <a:t>第 06 頁｜用真實需求，比較三種找家具的方法</a:t>
             </a:r>
           </a:p>
           <a:p>
@@ -1695,7 +1656,7 @@
                 <a:ea typeface="Noto Sans CJK TC"/>
                 <a:cs typeface="Noto Sans CJK TC"/>
               </a:rPr>
-              <a:t>評估要像一場公平的考試：先固定同一批題目和同一份候選清單，再讓不同方法作答。第一種是預訓練的 ULIP-2，把有提供的模態特徵依本地規則正規化後平均，作為起點。第二種是 Stage 1，經過物件配對訓練，學習在只有部分線索時仍找到對應資產。第三種是 Stage 2 訓練後的模型，但是作物件檢索時把場景資訊關掉，觀察它更新後的查詢融合能力。這一列和 Stage 1 使用同一個父模型的候選向量，避免一邊換查詢模型、一邊又換掉候選答案。每種方法都測文字、圖片、點雲，以及它們的四種組合，共七種條件。點雲就是物件表面的一組三維座標點，可以把它想成用許多小點勾出的立體輪廓。下一頁再把題目分成相同觀測與不同觀測兩個版本，所以總共是三乘七乘二，四十二組比較。這裡的平均融合是本地明示的基線，不是已經完整重建論文所有其他方法；Stage 1 與它的差異也可能包含點雲編碼器訓練，不能把分數差距全部歸功於融合設計。最新完整資料集的這份比較目前仍是待執行計畫。</a:t>
+              <a:t>這次主評估改成更接近使用者真正找家具的情境：我有一個需求，想從物件庫找出合適的選項，不一定要找回照片原本對應的那個檔案。比較的三種方法仍然相同。第一種是官方預訓練 ULIP-2 加上本地平均融合；第二種是經過物件配對訓練的 Stage 1；第三種是 Stage 2 訓練後、關閉場景資訊的查詢融合。第三列沿用指定 Stage 1 的候選向量，避免換查詢模型時連候選也一起改變。線索可以是需求文字、參考照片或參考點雲；點雲就像用小點畫出的立體輪廓。有提供足夠參考資料時，才安排七種模態組合。沒有照片或點雲的需求，不能自動補上某個正解資產的資料。我們會事先固定每個條件的題目與分母，因此不再承諾固定四十二組主評估；原本兩觀測乘三方法乘七模態的四十二組，只保留作同資產辨識診斷。</a:t>
             </a:r>
           </a:p>
           <a:p/>
@@ -1709,7 +1670,7 @@
                 <a:ea typeface="Noto Sans CJK TC"/>
                 <a:cs typeface="Noto Sans CJK TC"/>
               </a:rPr>
-              <a:t>本頁重點：3 種方法 × 7 種模態組合 × 2 種觀測＝42 組比較。</a:t>
+              <a:t>本頁重點：主評估問「是否符合需求」；三種方法使用同一題目、候選與正解。</a:t>
             </a:r>
           </a:p>
           <a:p/>
@@ -1736,7 +1697,7 @@
                 <a:ea typeface="Noto Sans CJK TC"/>
                 <a:cs typeface="Noto Sans CJK TC"/>
               </a:rPr>
-              <a:t>docs/CUSTOM_TABLE1_EVALUATION.md#L33</a:t>
+              <a:t>docs/INTENT_RETRIEVAL_EVALUATION.md#L21</a:t>
             </a:r>
           </a:p>
           <a:p>
@@ -1749,7 +1710,7 @@
                 <a:ea typeface="Noto Sans CJK TC"/>
                 <a:cs typeface="Noto Sans CJK TC"/>
               </a:rPr>
-              <a:t>metafind/eval/custom_table1.py#L24</a:t>
+              <a:t>metafind/eval/custom_models.py#L52</a:t>
             </a:r>
           </a:p>
           <a:p>
@@ -1762,7 +1723,7 @@
                 <a:ea typeface="Noto Sans CJK TC"/>
                 <a:cs typeface="Noto Sans CJK TC"/>
               </a:rPr>
-              <a:t>docs/paper/metafind_source/3experiments.tex#L15</a:t>
+              <a:t>metafind/eval/custom_table1.py#L64</a:t>
             </a:r>
           </a:p>
           <a:p>
@@ -1853,7 +1814,7 @@
                 <a:ea typeface="Noto Sans CJK TC"/>
                 <a:cs typeface="Noto Sans CJK TC"/>
               </a:rPr>
-              <a:t>第 07 頁｜換一份線索，還找得到同一件資產嗎？</a:t>
+              <a:t>第 07 頁｜一道需求，可以有好幾個合適答案</a:t>
             </a:r>
           </a:p>
           <a:p>
@@ -1880,7 +1841,7 @@
                 <a:ea typeface="Noto Sans CJK TC"/>
                 <a:cs typeface="Noto Sans CJK TC"/>
               </a:rPr>
-              <a:t>這兩個版本可以用找人的比喻來理解。第一版拿的是原本那張資料卡和原本那些照片；第二版換一份描述、換一個觀看角度，再看能否找回同一個人。放到三維資產上，答案始終是同一個唯一編號，而不是只要看起來同類就算對。相同觀測組使用原有文字、全部視角的平均特徵與原有點雲；不同觀測組使用另外提供的文字、一個固定視角，以及同一網格重新取樣的點雲。對現在十一個視角的資料，圖片查詢取一張，候選端取剩下十張的平均，避免把查詢那一張也放進候選圖片特徵。所有候選都預先固定這個規則，不會每次看到查詢才臨時改題目。計分很直覺：第一名就是答案的比例叫 R@1，前五名包含答案的比例叫 R@5。另一份描述還需要確認模型實際讀到的文字確實不同，不能只改掉被截斷的句尾。最後，相同觀測不代表不同編碼器必然產生相同向量；不同觀測也仍然來自同一資產，不能直接稱為獨立物件的泛化測試。</a:t>
+              <a:t>例如使用者說，想找一張適合小餐桌、木質外觀的餐椅。這是一個需求，不是一個資產編號；物件庫裡可能有好幾張不同椅子都能接受。投影片上的例子完全是教學示意：八個候選裡，事先有三個被判定合適，模型把它們排在第二、第六和第八名。第一名沒有找對，所以這題的 Hit@1 是零；前五名已有一個合適答案，因此 Hit@5 算成功。但前五名只找回三個正解中的一個，所以真正的 Recall@5 是三分之一。正式報告會把這些逐題結果平均。這兩種指標回答不同問題，不能都叫成論文的 R@5。還有，答案必須依模型當下看得到的線索判定。只有照片的條件，不能拿沒有提供的文字尺寸限制偷偷扣分。因此同一個需求在文字、圖片或組合條件下，會各自有一份審核答案。這些真實題目與答案目前仍待建立。</a:t>
             </a:r>
           </a:p>
           <a:p/>
@@ -1894,7 +1855,7 @@
                 <a:ea typeface="Noto Sans CJK TC"/>
                 <a:cs typeface="Noto Sans CJK TC"/>
               </a:rPr>
-              <a:t>本頁重點：答案仍是同一個 UID；更換觀測，檢查是否還能找回它。</a:t>
+              <a:t>本頁重點：主要看 Hit@1／Hit@5：前 1／5 名是否至少有一個可接受選項。</a:t>
             </a:r>
           </a:p>
           <a:p/>
@@ -1921,7 +1882,7 @@
                 <a:ea typeface="Noto Sans CJK TC"/>
                 <a:cs typeface="Noto Sans CJK TC"/>
               </a:rPr>
-              <a:t>docs/CUSTOM_TABLE1_EVALUATION.md#L15</a:t>
+              <a:t>docs/INTENT_RETRIEVAL_EVALUATION.md#L9</a:t>
             </a:r>
           </a:p>
           <a:p>
@@ -1934,33 +1895,7 @@
                 <a:ea typeface="Noto Sans CJK TC"/>
                 <a:cs typeface="Noto Sans CJK TC"/>
               </a:rPr>
-              <a:t>docs/CUSTOM_TABLE1_EVALUATION.md#L25</a:t>
-            </a:r>
-          </a:p>
-          <a:p>
-            <a:r>
-              <a:rPr sz="1200" b="0">
-                <a:solidFill>
-                  <a:srgbClr val="183247"/>
-                </a:solidFill>
-                <a:latin typeface="Noto Sans CJK TC"/>
-                <a:ea typeface="Noto Sans CJK TC"/>
-                <a:cs typeface="Noto Sans CJK TC"/>
-              </a:rPr>
-              <a:t>metafind/eval/custom_table1.py#L192</a:t>
-            </a:r>
-          </a:p>
-          <a:p>
-            <a:r>
-              <a:rPr sz="1200" b="0">
-                <a:solidFill>
-                  <a:srgbClr val="183247"/>
-                </a:solidFill>
-                <a:latin typeface="Noto Sans CJK TC"/>
-                <a:ea typeface="Noto Sans CJK TC"/>
-                <a:cs typeface="Noto Sans CJK TC"/>
-              </a:rPr>
-              <a:t>metafind/eval/custom_table1.py#L212</a:t>
+              <a:t>docs/INTENT_RETRIEVAL_EVALUATION.md#L116</a:t>
             </a:r>
           </a:p>
         </p:txBody>
@@ -2038,7 +1973,7 @@
                 <a:ea typeface="Noto Sans CJK TC"/>
                 <a:cs typeface="Noto Sans CJK TC"/>
               </a:rPr>
-              <a:t>第 08 頁｜和論文可能不同、尚不確定的地方</a:t>
+              <a:t>第 08 頁｜新主評估與論文、舊診斷分開看</a:t>
             </a:r>
           </a:p>
           <a:p>
@@ -2065,7 +2000,7 @@
                 <a:ea typeface="Noto Sans CJK TC"/>
                 <a:cs typeface="Noto Sans CJK TC"/>
               </a:rPr>
-              <a:t>比較結果之前，先把哪些地方相同、哪些地方仍不同說清楚，才知道數字能回答什麼問題。論文明確列出七種模態以及 R@1、R@5，我們沿用這些項目；但作者每筆查詢怎麼配對、候選清單到底有哪些唯一編號，沒有完整公開，因此本地兩種觀測的規則不能冒充作者原始設定。候選池多大、有哪些相似物件，都可能改變檢索難度，不能只因為同樣用了 Objaverse-LVIS 就認為完全可比。訓練方面，論文描述 Stage 1 兩塔訓練，現行程式則使用凍結的 CLIP 文字與圖片特徵，這個界線必須保留。現行選模又與部分評估範圍重疊，已有小型驗證也有重疊紀錄，不能把它們稱為從未用過的獨立測試。平均融合的正規化順序同樣是本地明示的選擇。還有，Stage 2 關閉場景資訊那一列，只是在檢查第二階段訓練後的物件檢索，不是在證明場景資訊有效或場景更美觀。因此這次先做透明的本地對照，避免直接把結果冠上作者 Table 1 已復現的結論。</a:t>
+              <a:t>這一頁先畫清楚比較界線。論文明確列出七種模態，並稱指標為 R@1 和 R@5，但沒有完整公開每道查詢如何形成，以及所有可接受答案怎麼標註。因此，我們不能說作者一定採用同一資產作唯一正解，也不能說新的需求評估就是作者原始設定。新的主指標明確叫 Hit，另外報真正的 Recall，避免名稱相同卻分母不同。點雲基線也要注意：論文提到其他模型在只有點雲時，兩邊用了相同 embedding；本地平均基線的候選一直是文字、圖片和點雲的融合，並不具備必然自我相等的條件。此外，完整人工審核可能先從固定小候選池開始，但不能在看見分數後刪掉困難候選，也不能把小池高分直接對照論文的大池結果。CLIP 凍結與已知選模重疊仍需保留。原本同 UID 的四十二組繼續作診斷，與新主評估分開呈現。</a:t>
             </a:r>
           </a:p>
           <a:p/>
@@ -2079,7 +2014,7 @@
                 <a:ea typeface="Noto Sans CJK TC"/>
                 <a:cs typeface="Noto Sans CJK TC"/>
               </a:rPr>
-              <a:t>本頁重點：可比較的部分沿用；作者未公開的細節，保留未知並揭露差異。</a:t>
+              <a:t>本頁重點：這是已批准的本地需求檢索評估；不冒充作者 Table 1 原始協定。</a:t>
             </a:r>
           </a:p>
           <a:p/>
@@ -2106,7 +2041,7 @@
                 <a:ea typeface="Noto Sans CJK TC"/>
                 <a:cs typeface="Noto Sans CJK TC"/>
               </a:rPr>
-              <a:t>docs/paper/metafind_source/3experiments.tex#L8</a:t>
+              <a:t>docs/INTENT_RETRIEVAL_EVALUATION.md#L142</a:t>
             </a:r>
           </a:p>
           <a:p>
@@ -2132,6 +2067,19 @@
                 <a:ea typeface="Noto Sans CJK TC"/>
                 <a:cs typeface="Noto Sans CJK TC"/>
               </a:rPr>
+              <a:t>docs/paper/metafind_source/3experiments.tex#L18</a:t>
+            </a:r>
+          </a:p>
+          <a:p>
+            <a:r>
+              <a:rPr sz="1200" b="0">
+                <a:solidFill>
+                  <a:srgbClr val="183247"/>
+                </a:solidFill>
+                <a:latin typeface="Noto Sans CJK TC"/>
+                <a:ea typeface="Noto Sans CJK TC"/>
+                <a:cs typeface="Noto Sans CJK TC"/>
+              </a:rPr>
               <a:t>docs/paper/metafind_source/3experiments.tex#L24</a:t>
             </a:r>
           </a:p>
@@ -2145,46 +2093,7 @@
                 <a:ea typeface="Noto Sans CJK TC"/>
                 <a:cs typeface="Noto Sans CJK TC"/>
               </a:rPr>
-              <a:t>docs/paper/metafind_source/2methdology.tex#L75</a:t>
-            </a:r>
-          </a:p>
-          <a:p>
-            <a:r>
-              <a:rPr sz="1200" b="0">
-                <a:solidFill>
-                  <a:srgbClr val="183247"/>
-                </a:solidFill>
-                <a:latin typeface="Noto Sans CJK TC"/>
-                <a:ea typeface="Noto Sans CJK TC"/>
-                <a:cs typeface="Noto Sans CJK TC"/>
-              </a:rPr>
-              <a:t>metafind/train/stage1.py#L511</a:t>
-            </a:r>
-          </a:p>
-          <a:p>
-            <a:r>
-              <a:rPr sz="1200" b="0">
-                <a:solidFill>
-                  <a:srgbClr val="183247"/>
-                </a:solidFill>
-                <a:latin typeface="Noto Sans CJK TC"/>
-                <a:ea typeface="Noto Sans CJK TC"/>
-                <a:cs typeface="Noto Sans CJK TC"/>
-              </a:rPr>
-              <a:t>tools/chain_paper_stage1.sh#L119</a:t>
-            </a:r>
-          </a:p>
-          <a:p>
-            <a:r>
-              <a:rPr sz="1200" b="0">
-                <a:solidFill>
-                  <a:srgbClr val="183247"/>
-                </a:solidFill>
-                <a:latin typeface="Noto Sans CJK TC"/>
-                <a:ea typeface="Noto Sans CJK TC"/>
-                <a:cs typeface="Noto Sans CJK TC"/>
-              </a:rPr>
-              <a:t>docs/audit/validation_artifacts_20260907_08/custom_table1_cpu_new_stages_20260908/verification.json#L11</a:t>
+              <a:t>docs/CUSTOM_TABLE1_EVALUATION.md#L48</a:t>
             </a:r>
           </a:p>
         </p:txBody>
@@ -2262,7 +2171,7 @@
                 <a:ea typeface="Noto Sans CJK TC"/>
                 <a:cs typeface="Noto Sans CJK TC"/>
               </a:rPr>
-              <a:t>第 09 頁｜正式跑分前，先固定題目與規則</a:t>
+              <a:t>第 09 頁｜先寫題、審答案、封存，最後才跑模型</a:t>
             </a:r>
           </a:p>
           <a:p>
@@ -2289,7 +2198,7 @@
                 <a:ea typeface="Noto Sans CJK TC"/>
                 <a:cs typeface="Noto Sans CJK TC"/>
               </a:rPr>
-              <a:t>正式跑分前，最重要的不是先把運算按下去，而是先把考卷封存好。第一，決定這次查詢到底有哪些資產編號，另一份文字是誰寫的、哪個模型產生的，來源都要記下來。第二，固定 Stage 1 和 Stage 2 使用的訓練權重，確認第二階段接的是指定的第一階段，而不是碰巧檔名相似的另一個模型。第三，固定候選清單與順序，並用唯一編號建立每一題的正解，不能假設表格對角線天然就是答案。第四，除了總平均，還要保存每一題的排名、第一名和同分情形，之後才有辦法找到哪種線索容易失敗。如果看完分數後才換題目、縮候選池或重新挑模型，結果就需要當作開發比較，不能再說是獨立測試。目前我們已經在很小的真實輸入範圍跑通模型載入、兩種觀測、七種模態和逐題計分，這是流程可執行的證據。最新完整資料集搭配完整新權重的正式比較尚未執行，所以這一頁不展示模型成績，也不以程式測試的數量代替檢索效果。</a:t>
+              <a:t>正式評估最重要的順序，是先建立題目和答案，再讓模型作答。首先，替每個家具需求建立獨立編號，保存實際提供的文字、照片或點雲，以及誰提供、從哪裡取得。ULIP-2 原始描述可以協助起草，但還須人工確認是否表達這道需求，不能自動產生正解。接著，審核者只能依該模態條件看得到的線索，判斷固定候選池裡每件物件能否接受。每件都要標成零或一，至少有一個可接受答案；漏標不能直接算零。如果池子太大，可以在看模型結果之前先決定較小的固定池，並完整審完。Gemma 標出的尺寸與材質可以作參考，但它們是估計，不能直接冒充量測真值或替代已聲明的審核依據。答案、題目、模型與候選版本都封存後，才開始排名。若看過結果又改規則或答案，就需要新版本並揭露其開發性質。目前真實需求與完整人工正解仍待建立，新主評估沒有正式分數；既有程式或同資產診斷也不能替這件事宣布完成。</a:t>
             </a:r>
           </a:p>
           <a:p/>
@@ -2303,7 +2212,7 @@
                 <a:ea typeface="Noto Sans CJK TC"/>
                 <a:cs typeface="Noto Sans CJK TC"/>
               </a:rPr>
-              <a:t>本頁重點：先固定輸入、模型和正解，再跑分；看完結果不換題目。</a:t>
+              <a:t>本頁重點：每題、每個模態條件，都先審完固定候選池；未審完就是待完成。</a:t>
             </a:r>
           </a:p>
           <a:p/>
@@ -2330,7 +2239,7 @@
                 <a:ea typeface="Noto Sans CJK TC"/>
                 <a:cs typeface="Noto Sans CJK TC"/>
               </a:rPr>
-              <a:t>docs/CUSTOM_TABLE1_EVALUATION.md#L44</a:t>
+              <a:t>docs/INTENT_RETRIEVAL_EVALUATION.md#L54</a:t>
             </a:r>
           </a:p>
           <a:p>
@@ -2343,7 +2252,7 @@
                 <a:ea typeface="Noto Sans CJK TC"/>
                 <a:cs typeface="Noto Sans CJK TC"/>
               </a:rPr>
-              <a:t>docs/CUSTOM_TABLE1_EVALUATION.md#L83</a:t>
+              <a:t>metafind/data/annotate_v10.py#L268</a:t>
             </a:r>
           </a:p>
           <a:p>
@@ -2356,33 +2265,7 @@
                 <a:ea typeface="Noto Sans CJK TC"/>
                 <a:cs typeface="Noto Sans CJK TC"/>
               </a:rPr>
-              <a:t>docs/CUSTOM_TABLE1_EVALUATION.md#L124</a:t>
-            </a:r>
-          </a:p>
-          <a:p>
-            <a:r>
-              <a:rPr sz="1200" b="0">
-                <a:solidFill>
-                  <a:srgbClr val="183247"/>
-                </a:solidFill>
-                <a:latin typeface="Noto Sans CJK TC"/>
-                <a:ea typeface="Noto Sans CJK TC"/>
-                <a:cs typeface="Noto Sans CJK TC"/>
-              </a:rPr>
-              <a:t>docs/CUSTOM_TABLE1_EVALUATION.md#L152</a:t>
-            </a:r>
-          </a:p>
-          <a:p>
-            <a:r>
-              <a:rPr sz="1200" b="0">
-                <a:solidFill>
-                  <a:srgbClr val="183247"/>
-                </a:solidFill>
-                <a:latin typeface="Noto Sans CJK TC"/>
-                <a:ea typeface="Noto Sans CJK TC"/>
-                <a:cs typeface="Noto Sans CJK TC"/>
-              </a:rPr>
-              <a:t>metafind/eval/custom_table1.py#L215</a:t>
+              <a:t>docs/INTENT_RETRIEVAL_EVALUATION.md#L68</a:t>
             </a:r>
           </a:p>
         </p:txBody>
@@ -6138,7 +6021,7 @@
                 <a:ea typeface="Noto Sans CJK TC"/>
                 <a:cs typeface="Noto Sans CJK TC"/>
               </a:rPr>
-              <a:t>標註結束後，依序完成六步</a:t>
+              <a:t>標註後，補齊資料、模型與需求考卷</a:t>
             </a:r>
           </a:p>
         </p:txBody>
@@ -6263,7 +6146,7 @@
                 <a:ea typeface="Noto Sans CJK TC"/>
                 <a:cs typeface="Noto Sans CJK TC"/>
               </a:rPr>
-              <a:t>先固定資料，再訓練、建候選庫，最後另行執行正式評估。</a:t>
+              <a:t>完整題目與正解先封存，模型準備好後再另行執行主評估。</a:t>
             </a:r>
           </a:p>
         </p:txBody>
@@ -6310,7 +6193,7 @@
                 <a:ea typeface="Noto Sans CJK TC"/>
                 <a:cs typeface="Noto Sans CJK TC"/>
               </a:rPr>
-              <a:t>來源：論文 Table 1、目前自訂評估規格與程式｜完整依據見備忘稿</a:t>
+              <a:t>來源：論文 Table 1 與本地需求檢索規格；正式評估尚待執行｜完整依據見備忘稿</a:t>
             </a:r>
           </a:p>
         </p:txBody>
@@ -6545,7 +6428,7 @@
                 <a:ea typeface="Noto Sans CJK TC"/>
                 <a:cs typeface="Noto Sans CJK TC"/>
               </a:rPr>
-              <a:t>對清有效資產、真實失敗與人工排除</a:t>
+              <a:t>對清有效資產、真正失敗與人工排除</a:t>
             </a:r>
           </a:p>
         </p:txBody>
@@ -6733,7 +6616,7 @@
                 <a:ea typeface="Noto Sans CJK TC"/>
                 <a:cs typeface="Noto Sans CJK TC"/>
               </a:rPr>
-              <a:t>編碼與資料切分</a:t>
+              <a:t>編碼與固定切分</a:t>
             </a:r>
           </a:p>
         </p:txBody>
@@ -6780,7 +6663,7 @@
                 <a:ea typeface="Noto Sans CJK TC"/>
                 <a:cs typeface="Noto Sans CJK TC"/>
               </a:rPr>
-              <a:t>轉成向量、固定資料分組；另做資料預檢</a:t>
+              <a:t>建立特徵、固定分組，另做資料預檢</a:t>
             </a:r>
           </a:p>
         </p:txBody>
@@ -6968,7 +6851,7 @@
                 <a:ea typeface="Noto Sans CJK TC"/>
                 <a:cs typeface="Noto Sans CJK TC"/>
               </a:rPr>
-              <a:t>Stage 1 物件訓練</a:t>
+              <a:t>訓練兩階段模型</a:t>
             </a:r>
           </a:p>
         </p:txBody>
@@ -7015,7 +6898,7 @@
                 <a:ea typeface="Noto Sans CJK TC"/>
                 <a:cs typeface="Noto Sans CJK TC"/>
               </a:rPr>
-              <a:t>學習物件配對；保存模型與選模範圍</a:t>
+              <a:t>Stage 1／候選庫核驗，再備妥 Stage 2</a:t>
             </a:r>
           </a:p>
         </p:txBody>
@@ -7156,7 +7039,7 @@
                 <a:ea typeface="Noto Sans CJK TC"/>
                 <a:cs typeface="Noto Sans CJK TC"/>
               </a:rPr>
-              <a:t>建立候選物件庫</a:t>
+              <a:t>撰寫真實需求</a:t>
             </a:r>
           </a:p>
         </p:txBody>
@@ -7203,7 +7086,7 @@
                 <a:ea typeface="Noto Sans CJK TC"/>
                 <a:cs typeface="Noto Sans CJK TC"/>
               </a:rPr>
-              <a:t>計算候選向量，核驗後固定版本</a:t>
+              <a:t>獨立 query ID；選定可用參考線索</a:t>
             </a:r>
           </a:p>
         </p:txBody>
@@ -7391,7 +7274,7 @@
                 <a:ea typeface="Noto Sans CJK TC"/>
                 <a:cs typeface="Noto Sans CJK TC"/>
               </a:rPr>
-              <a:t>Stage 2 場景訓練</a:t>
+              <a:t>審核與封存答案</a:t>
             </a:r>
           </a:p>
         </p:txBody>
@@ -7438,7 +7321,7 @@
                 <a:ea typeface="Noto Sans CJK TC"/>
                 <a:cs typeface="Noto Sans CJK TC"/>
               </a:rPr>
-              <a:t>準備房間、物件與關係，訓練第二階段</a:t>
+              <a:t>每條件完整 0／1 正解；先於模型排名</a:t>
             </a:r>
           </a:p>
         </p:txBody>
@@ -7624,7 +7507,7 @@
                 <a:ea typeface="Noto Sans CJK TC"/>
                 <a:cs typeface="Noto Sans CJK TC"/>
               </a:rPr>
-              <a:t>正式評估與診斷</a:t>
+              <a:t>執行並報告結果</a:t>
             </a:r>
           </a:p>
         </p:txBody>
@@ -7671,7 +7554,7 @@
                 <a:ea typeface="Noto Sans CJK TC"/>
                 <a:cs typeface="Noto Sans CJK TC"/>
               </a:rPr>
-              <a:t>跑 42 組比較；另測場景資訊開啟／關閉</a:t>
+              <a:t>Hit@1／Hit@5；另列 Recall 與舊診斷</a:t>
             </a:r>
           </a:p>
         </p:txBody>
@@ -13982,7 +13865,7 @@
                 <a:ea typeface="Noto Sans CJK TC"/>
                 <a:cs typeface="Noto Sans CJK TC"/>
               </a:rPr>
-              <a:t>同一批題目，比較三種方法</a:t>
+              <a:t>用真實需求，比較三種找家具的方法</a:t>
             </a:r>
           </a:p>
         </p:txBody>
@@ -14107,7 +13990,7 @@
                 <a:ea typeface="Noto Sans CJK TC"/>
                 <a:cs typeface="Noto Sans CJK TC"/>
               </a:rPr>
-              <a:t>3 種方法 × 7 種模態組合 × 2 種觀測＝42 組比較。</a:t>
+              <a:t>主評估問「是否符合需求」；三種方法使用同一題目、候選與正解。</a:t>
             </a:r>
           </a:p>
         </p:txBody>
@@ -14154,7 +14037,7 @@
                 <a:ea typeface="Noto Sans CJK TC"/>
                 <a:cs typeface="Noto Sans CJK TC"/>
               </a:rPr>
-              <a:t>來源：論文 Table 1、目前自訂評估規格與程式｜完整依據見備忘稿</a:t>
+              <a:t>來源：論文 Table 1 與本地需求檢索規格；正式評估尚待執行｜完整依據見備忘稿</a:t>
             </a:r>
           </a:p>
         </p:txBody>
@@ -14882,7 +14765,7 @@
                 <a:ea typeface="Noto Sans CJK TC"/>
                 <a:cs typeface="Noto Sans CJK TC"/>
               </a:rPr>
-              <a:t>7 種線索組合</a:t>
+              <a:t>依輸入安排條件</a:t>
             </a:r>
           </a:p>
         </p:txBody>
@@ -14943,7 +14826,7 @@
         <p:spPr>
           <a:xfrm>
             <a:off x="667512" y="5303520"/>
-            <a:ext cx="5029200" cy="338328"/>
+            <a:ext cx="5029200" cy="384048"/>
           </a:xfrm>
           <a:prstGeom prst="rect">
             <a:avLst/>
@@ -14968,7 +14851,7 @@
               </a:spcAft>
             </a:pPr>
             <a:r>
-              <a:rPr sz="1600" b="0">
+              <a:rPr sz="1500" b="0">
                 <a:solidFill>
                   <a:srgbClr val="657A88"/>
                 </a:solidFill>
@@ -14976,7 +14859,7 @@
                 <a:ea typeface="Noto Sans CJK TC"/>
                 <a:cs typeface="Noto Sans CJK TC"/>
               </a:rPr>
-              <a:t>T＝文字　I＝圖片　PC＝點雲</a:t>
+              <a:t>T＝文字　I＝圖片　PC＝點雲；逐條件記錄題數</a:t>
             </a:r>
           </a:p>
         </p:txBody>
@@ -15186,7 +15069,7 @@
                 <a:ea typeface="Noto Sans CJK TC"/>
                 <a:cs typeface="Noto Sans CJK TC"/>
               </a:rPr>
-              <a:t>換一份線索，還找得到同一件資產嗎？</a:t>
+              <a:t>一道需求，可以有好幾個合適答案</a:t>
             </a:r>
           </a:p>
         </p:txBody>
@@ -15311,7 +15194,7 @@
                 <a:ea typeface="Noto Sans CJK TC"/>
                 <a:cs typeface="Noto Sans CJK TC"/>
               </a:rPr>
-              <a:t>答案仍是同一個 UID；更換觀測，檢查是否還能找回它。</a:t>
+              <a:t>主要看 Hit@1／Hit@5：前 1／5 名是否至少有一個可接受選項。</a:t>
             </a:r>
           </a:p>
         </p:txBody>
@@ -15358,7 +15241,7 @@
                 <a:ea typeface="Noto Sans CJK TC"/>
                 <a:cs typeface="Noto Sans CJK TC"/>
               </a:rPr>
-              <a:t>來源：論文 Table 1、目前自訂評估規格與程式｜完整依據見備忘稿</a:t>
+              <a:t>來源：論文 Table 1 與本地需求檢索規格；正式評估尚待執行｜完整依據見備忘稿</a:t>
             </a:r>
           </a:p>
         </p:txBody>
@@ -15412,14 +15295,61 @@
       </p:sp>
       <p:sp>
         <p:nvSpPr>
-          <p:cNvPr id="10" name="Rectangle 9"/>
+          <p:cNvPr id="10" name="TextBox 9"/>
+          <p:cNvSpPr txBox="1"/>
+          <p:nvPr/>
+        </p:nvSpPr>
+        <p:spPr>
+          <a:xfrm>
+            <a:off x="667512" y="1728216"/>
+            <a:ext cx="10908792" cy="438912"/>
+          </a:xfrm>
+          <a:prstGeom prst="rect">
+            <a:avLst/>
+          </a:prstGeom>
+          <a:noFill/>
+        </p:spPr>
+        <p:txBody>
+          <a:bodyPr wrap="square" lIns="13716" rIns="13716" tIns="9144" bIns="9144">
+            <a:spAutoFit/>
+          </a:bodyPr>
+          <a:lstStyle/>
+          <a:p>
+            <a:pPr algn="l">
+              <a:lnSpc>
+                <a:spcPct val="112000"/>
+              </a:lnSpc>
+              <a:spcBef>
+                <a:spcPts val="0"/>
+              </a:spcBef>
+              <a:spcAft>
+                <a:spcPts val="200"/>
+              </a:spcAft>
+            </a:pPr>
+            <a:r>
+              <a:rPr sz="2300" b="1">
+                <a:solidFill>
+                  <a:srgbClr val="137D88"/>
+                </a:solidFill>
+                <a:latin typeface="Noto Sans CJK TC"/>
+                <a:ea typeface="Noto Sans CJK TC"/>
+                <a:cs typeface="Noto Sans CJK TC"/>
+              </a:rPr>
+              <a:t>需求：找一張適合小餐桌、木質外觀的餐椅。</a:t>
+            </a:r>
+          </a:p>
+        </p:txBody>
+      </p:sp>
+      <p:sp>
+        <p:nvSpPr>
+          <p:cNvPr id="11" name="Rectangle 10"/>
           <p:cNvSpPr/>
           <p:nvPr/>
         </p:nvSpPr>
         <p:spPr>
           <a:xfrm>
-            <a:off x="548640" y="1773936"/>
-            <a:ext cx="1712322" cy="493776"/>
+            <a:off x="548640" y="2377440"/>
+            <a:ext cx="5089550" cy="493776"/>
           </a:xfrm>
           <a:prstGeom prst="rect">
             <a:avLst/>
@@ -15455,14 +15385,14 @@
       </p:sp>
       <p:sp>
         <p:nvSpPr>
-          <p:cNvPr id="11" name="TextBox 10"/>
+          <p:cNvPr id="12" name="TextBox 11"/>
           <p:cNvSpPr txBox="1"/>
           <p:nvPr/>
         </p:nvSpPr>
         <p:spPr>
           <a:xfrm>
-            <a:off x="640080" y="1828800"/>
-            <a:ext cx="1529442" cy="402336"/>
+            <a:off x="640080" y="2432304"/>
+            <a:ext cx="4906670" cy="402336"/>
           </a:xfrm>
           <a:prstGeom prst="rect">
             <a:avLst/>
@@ -15495,21 +15425,21 @@
                 <a:ea typeface="Noto Sans CJK TC"/>
                 <a:cs typeface="Noto Sans CJK TC"/>
               </a:rPr>
-              <a:t>查詢線索</a:t>
-            </a:r>
-          </a:p>
-        </p:txBody>
-      </p:sp>
-      <p:sp>
-        <p:nvSpPr>
-          <p:cNvPr id="12" name="Rectangle 11"/>
+              <a:t>示意結果</a:t>
+            </a:r>
+          </a:p>
+        </p:txBody>
+      </p:sp>
+      <p:sp>
+        <p:nvSpPr>
+          <p:cNvPr id="13" name="Rectangle 12"/>
           <p:cNvSpPr/>
           <p:nvPr/>
         </p:nvSpPr>
         <p:spPr>
           <a:xfrm>
-            <a:off x="2260962" y="1773936"/>
-            <a:ext cx="3292928" cy="493776"/>
+            <a:off x="5638190" y="2377440"/>
+            <a:ext cx="5974689" cy="493776"/>
           </a:xfrm>
           <a:prstGeom prst="rect">
             <a:avLst/>
@@ -15545,14 +15475,14 @@
       </p:sp>
       <p:sp>
         <p:nvSpPr>
-          <p:cNvPr id="13" name="TextBox 12"/>
+          <p:cNvPr id="14" name="TextBox 13"/>
           <p:cNvSpPr txBox="1"/>
           <p:nvPr/>
         </p:nvSpPr>
         <p:spPr>
           <a:xfrm>
-            <a:off x="2352402" y="1828800"/>
-            <a:ext cx="3110048" cy="402336"/>
+            <a:off x="5729630" y="2432304"/>
+            <a:ext cx="5791809" cy="402336"/>
           </a:xfrm>
           <a:prstGeom prst="rect">
             <a:avLst/>
@@ -15585,111 +15515,21 @@
                 <a:ea typeface="Noto Sans CJK TC"/>
                 <a:cs typeface="Noto Sans CJK TC"/>
               </a:rPr>
-              <a:t>相同觀測</a:t>
-            </a:r>
-          </a:p>
-        </p:txBody>
-      </p:sp>
-      <p:sp>
-        <p:nvSpPr>
-          <p:cNvPr id="14" name="Rectangle 13"/>
+              <a:t>怎麼解讀</a:t>
+            </a:r>
+          </a:p>
+        </p:txBody>
+      </p:sp>
+      <p:sp>
+        <p:nvSpPr>
+          <p:cNvPr id="15" name="Rectangle 14"/>
           <p:cNvSpPr/>
           <p:nvPr/>
         </p:nvSpPr>
         <p:spPr>
           <a:xfrm>
-            <a:off x="5553891" y="1773936"/>
-            <a:ext cx="6058988" cy="493776"/>
-          </a:xfrm>
-          <a:prstGeom prst="rect">
-            <a:avLst/>
-          </a:prstGeom>
-          <a:solidFill>
-            <a:srgbClr val="183247"/>
-          </a:solidFill>
-          <a:ln>
-            <a:noFill/>
-          </a:ln>
-        </p:spPr>
-        <p:style>
-          <a:lnRef idx="1">
-            <a:schemeClr val="accent1"/>
-          </a:lnRef>
-          <a:fillRef idx="3">
-            <a:schemeClr val="accent1"/>
-          </a:fillRef>
-          <a:effectRef idx="2">
-            <a:schemeClr val="accent1"/>
-          </a:effectRef>
-          <a:fontRef idx="minor">
-            <a:schemeClr val="lt1"/>
-          </a:fontRef>
-        </p:style>
-        <p:txBody>
-          <a:bodyPr rtlCol="0" anchor="ctr"/>
-          <a:lstStyle/>
-          <a:p>
-            <a:pPr algn="ctr"/>
-          </a:p>
-        </p:txBody>
-      </p:sp>
-      <p:sp>
-        <p:nvSpPr>
-          <p:cNvPr id="15" name="TextBox 14"/>
-          <p:cNvSpPr txBox="1"/>
-          <p:nvPr/>
-        </p:nvSpPr>
-        <p:spPr>
-          <a:xfrm>
-            <a:off x="5645331" y="1828800"/>
-            <a:ext cx="5876108" cy="402336"/>
-          </a:xfrm>
-          <a:prstGeom prst="rect">
-            <a:avLst/>
-          </a:prstGeom>
-          <a:noFill/>
-        </p:spPr>
-        <p:txBody>
-          <a:bodyPr wrap="square" lIns="13716" rIns="13716" tIns="9144" bIns="9144" anchor="ctr">
-            <a:spAutoFit/>
-          </a:bodyPr>
-          <a:lstStyle/>
-          <a:p>
-            <a:pPr algn="l">
-              <a:lnSpc>
-                <a:spcPct val="112000"/>
-              </a:lnSpc>
-              <a:spcBef>
-                <a:spcPts val="0"/>
-              </a:spcBef>
-              <a:spcAft>
-                <a:spcPts val="200"/>
-              </a:spcAft>
-            </a:pPr>
-            <a:r>
-              <a:rPr sz="1700" b="1">
-                <a:solidFill>
-                  <a:srgbClr val="FFFFFF"/>
-                </a:solidFill>
-                <a:latin typeface="Noto Sans CJK TC"/>
-                <a:ea typeface="Noto Sans CJK TC"/>
-                <a:cs typeface="Noto Sans CJK TC"/>
-              </a:rPr>
-              <a:t>不同觀測</a:t>
-            </a:r>
-          </a:p>
-        </p:txBody>
-      </p:sp>
-      <p:sp>
-        <p:nvSpPr>
-          <p:cNvPr id="16" name="Rectangle 15"/>
-          <p:cNvSpPr/>
-          <p:nvPr/>
-        </p:nvSpPr>
-        <p:spPr>
-          <a:xfrm>
-            <a:off x="548640" y="2267712"/>
-            <a:ext cx="1712322" cy="664464"/>
+            <a:off x="548640" y="2871216"/>
+            <a:ext cx="5089550" cy="425196"/>
           </a:xfrm>
           <a:prstGeom prst="rect">
             <a:avLst/>
@@ -15725,14 +15565,14 @@
       </p:sp>
       <p:sp>
         <p:nvSpPr>
-          <p:cNvPr id="17" name="TextBox 16"/>
+          <p:cNvPr id="16" name="TextBox 15"/>
           <p:cNvSpPr txBox="1"/>
           <p:nvPr/>
         </p:nvSpPr>
         <p:spPr>
           <a:xfrm>
-            <a:off x="640080" y="2322576"/>
-            <a:ext cx="1529442" cy="573024"/>
+            <a:off x="640080" y="2926080"/>
+            <a:ext cx="4906670" cy="333756"/>
           </a:xfrm>
           <a:prstGeom prst="rect">
             <a:avLst/>
@@ -15765,21 +15605,21 @@
                 <a:ea typeface="Noto Sans CJK TC"/>
                 <a:cs typeface="Noto Sans CJK TC"/>
               </a:rPr>
-              <a:t>文字 T</a:t>
-            </a:r>
-          </a:p>
-        </p:txBody>
-      </p:sp>
-      <p:sp>
-        <p:nvSpPr>
-          <p:cNvPr id="18" name="Rectangle 17"/>
+              <a:t>8 個候選，其中 3 個可接受</a:t>
+            </a:r>
+          </a:p>
+        </p:txBody>
+      </p:sp>
+      <p:sp>
+        <p:nvSpPr>
+          <p:cNvPr id="17" name="Rectangle 16"/>
           <p:cNvSpPr/>
           <p:nvPr/>
         </p:nvSpPr>
         <p:spPr>
           <a:xfrm>
-            <a:off x="2260962" y="2267712"/>
-            <a:ext cx="3292928" cy="664464"/>
+            <a:off x="5638190" y="2871216"/>
+            <a:ext cx="5974689" cy="425196"/>
           </a:xfrm>
           <a:prstGeom prst="rect">
             <a:avLst/>
@@ -15815,14 +15655,14 @@
       </p:sp>
       <p:sp>
         <p:nvSpPr>
-          <p:cNvPr id="19" name="TextBox 18"/>
+          <p:cNvPr id="18" name="TextBox 17"/>
           <p:cNvSpPr txBox="1"/>
           <p:nvPr/>
         </p:nvSpPr>
         <p:spPr>
           <a:xfrm>
-            <a:off x="2352402" y="2322576"/>
-            <a:ext cx="3110048" cy="573024"/>
+            <a:off x="5729630" y="2926080"/>
+            <a:ext cx="5791809" cy="333756"/>
           </a:xfrm>
           <a:prstGeom prst="rect">
             <a:avLst/>
@@ -15855,21 +15695,201 @@
                 <a:ea typeface="Noto Sans CJK TC"/>
                 <a:cs typeface="Noto Sans CJK TC"/>
               </a:rPr>
-              <a:t>原有描述</a:t>
-            </a:r>
-          </a:p>
-        </p:txBody>
-      </p:sp>
-      <p:sp>
-        <p:nvSpPr>
-          <p:cNvPr id="20" name="Rectangle 19"/>
+              <a:t>正解依需求審核；不靠同一個 UID</a:t>
+            </a:r>
+          </a:p>
+        </p:txBody>
+      </p:sp>
+      <p:sp>
+        <p:nvSpPr>
+          <p:cNvPr id="19" name="Rectangle 18"/>
           <p:cNvSpPr/>
           <p:nvPr/>
         </p:nvSpPr>
         <p:spPr>
           <a:xfrm>
-            <a:off x="5553891" y="2267712"/>
-            <a:ext cx="6058988" cy="664464"/>
+            <a:off x="548640" y="3296412"/>
+            <a:ext cx="5089550" cy="425196"/>
+          </a:xfrm>
+          <a:prstGeom prst="rect">
+            <a:avLst/>
+          </a:prstGeom>
+          <a:solidFill>
+            <a:srgbClr val="EBF0F3"/>
+          </a:solidFill>
+          <a:ln>
+            <a:noFill/>
+          </a:ln>
+        </p:spPr>
+        <p:style>
+          <a:lnRef idx="1">
+            <a:schemeClr val="accent1"/>
+          </a:lnRef>
+          <a:fillRef idx="3">
+            <a:schemeClr val="accent1"/>
+          </a:fillRef>
+          <a:effectRef idx="2">
+            <a:schemeClr val="accent1"/>
+          </a:effectRef>
+          <a:fontRef idx="minor">
+            <a:schemeClr val="lt1"/>
+          </a:fontRef>
+        </p:style>
+        <p:txBody>
+          <a:bodyPr rtlCol="0" anchor="ctr"/>
+          <a:lstStyle/>
+          <a:p>
+            <a:pPr algn="ctr"/>
+          </a:p>
+        </p:txBody>
+      </p:sp>
+      <p:sp>
+        <p:nvSpPr>
+          <p:cNvPr id="20" name="TextBox 19"/>
+          <p:cNvSpPr txBox="1"/>
+          <p:nvPr/>
+        </p:nvSpPr>
+        <p:spPr>
+          <a:xfrm>
+            <a:off x="640080" y="3351276"/>
+            <a:ext cx="4906670" cy="333756"/>
+          </a:xfrm>
+          <a:prstGeom prst="rect">
+            <a:avLst/>
+          </a:prstGeom>
+          <a:noFill/>
+        </p:spPr>
+        <p:txBody>
+          <a:bodyPr wrap="square" lIns="13716" rIns="13716" tIns="9144" bIns="9144" anchor="ctr">
+            <a:spAutoFit/>
+          </a:bodyPr>
+          <a:lstStyle/>
+          <a:p>
+            <a:pPr algn="l">
+              <a:lnSpc>
+                <a:spcPct val="112000"/>
+              </a:lnSpc>
+              <a:spcBef>
+                <a:spcPts val="0"/>
+              </a:spcBef>
+              <a:spcAft>
+                <a:spcPts val="200"/>
+              </a:spcAft>
+            </a:pPr>
+            <a:r>
+              <a:rPr sz="1700" b="1">
+                <a:solidFill>
+                  <a:srgbClr val="183247"/>
+                </a:solidFill>
+                <a:latin typeface="Noto Sans CJK TC"/>
+                <a:ea typeface="Noto Sans CJK TC"/>
+                <a:cs typeface="Noto Sans CJK TC"/>
+              </a:rPr>
+              <a:t>可接受候選排在第 2、6、8 名</a:t>
+            </a:r>
+          </a:p>
+        </p:txBody>
+      </p:sp>
+      <p:sp>
+        <p:nvSpPr>
+          <p:cNvPr id="21" name="Rectangle 20"/>
+          <p:cNvSpPr/>
+          <p:nvPr/>
+        </p:nvSpPr>
+        <p:spPr>
+          <a:xfrm>
+            <a:off x="5638190" y="3296412"/>
+            <a:ext cx="5974689" cy="425196"/>
+          </a:xfrm>
+          <a:prstGeom prst="rect">
+            <a:avLst/>
+          </a:prstGeom>
+          <a:solidFill>
+            <a:srgbClr val="EBF0F3"/>
+          </a:solidFill>
+          <a:ln>
+            <a:noFill/>
+          </a:ln>
+        </p:spPr>
+        <p:style>
+          <a:lnRef idx="1">
+            <a:schemeClr val="accent1"/>
+          </a:lnRef>
+          <a:fillRef idx="3">
+            <a:schemeClr val="accent1"/>
+          </a:fillRef>
+          <a:effectRef idx="2">
+            <a:schemeClr val="accent1"/>
+          </a:effectRef>
+          <a:fontRef idx="minor">
+            <a:schemeClr val="lt1"/>
+          </a:fontRef>
+        </p:style>
+        <p:txBody>
+          <a:bodyPr rtlCol="0" anchor="ctr"/>
+          <a:lstStyle/>
+          <a:p>
+            <a:pPr algn="ctr"/>
+          </a:p>
+        </p:txBody>
+      </p:sp>
+      <p:sp>
+        <p:nvSpPr>
+          <p:cNvPr id="22" name="TextBox 21"/>
+          <p:cNvSpPr txBox="1"/>
+          <p:nvPr/>
+        </p:nvSpPr>
+        <p:spPr>
+          <a:xfrm>
+            <a:off x="5729630" y="3351276"/>
+            <a:ext cx="5791809" cy="333756"/>
+          </a:xfrm>
+          <a:prstGeom prst="rect">
+            <a:avLst/>
+          </a:prstGeom>
+          <a:noFill/>
+        </p:spPr>
+        <p:txBody>
+          <a:bodyPr wrap="square" lIns="13716" rIns="13716" tIns="9144" bIns="9144" anchor="ctr">
+            <a:spAutoFit/>
+          </a:bodyPr>
+          <a:lstStyle/>
+          <a:p>
+            <a:pPr algn="l">
+              <a:lnSpc>
+                <a:spcPct val="112000"/>
+              </a:lnSpc>
+              <a:spcBef>
+                <a:spcPts val="0"/>
+              </a:spcBef>
+              <a:spcAft>
+                <a:spcPts val="200"/>
+              </a:spcAft>
+            </a:pPr>
+            <a:r>
+              <a:rPr sz="1700" b="0">
+                <a:solidFill>
+                  <a:srgbClr val="183247"/>
+                </a:solidFill>
+                <a:latin typeface="Noto Sans CJK TC"/>
+                <a:ea typeface="Noto Sans CJK TC"/>
+                <a:cs typeface="Noto Sans CJK TC"/>
+              </a:rPr>
+              <a:t>第一名不合適；前五名找到其中一個</a:t>
+            </a:r>
+          </a:p>
+        </p:txBody>
+      </p:sp>
+      <p:sp>
+        <p:nvSpPr>
+          <p:cNvPr id="23" name="Rectangle 22"/>
+          <p:cNvSpPr/>
+          <p:nvPr/>
+        </p:nvSpPr>
+        <p:spPr>
+          <a:xfrm>
+            <a:off x="548640" y="3721608"/>
+            <a:ext cx="5089550" cy="425196"/>
           </a:xfrm>
           <a:prstGeom prst="rect">
             <a:avLst/>
@@ -15905,14 +15925,14 @@
       </p:sp>
       <p:sp>
         <p:nvSpPr>
-          <p:cNvPr id="21" name="TextBox 20"/>
+          <p:cNvPr id="24" name="TextBox 23"/>
           <p:cNvSpPr txBox="1"/>
           <p:nvPr/>
         </p:nvSpPr>
         <p:spPr>
           <a:xfrm>
-            <a:off x="5645331" y="2322576"/>
-            <a:ext cx="5876108" cy="573024"/>
+            <a:off x="640080" y="3776472"/>
+            <a:ext cx="4906670" cy="333756"/>
           </a:xfrm>
           <a:prstGeom prst="rect">
             <a:avLst/>
@@ -15937,6 +15957,96 @@
               </a:spcAft>
             </a:pPr>
             <a:r>
+              <a:rPr sz="1700" b="1">
+                <a:solidFill>
+                  <a:srgbClr val="183247"/>
+                </a:solidFill>
+                <a:latin typeface="Noto Sans CJK TC"/>
+                <a:ea typeface="Noto Sans CJK TC"/>
+                <a:cs typeface="Noto Sans CJK TC"/>
+              </a:rPr>
+              <a:t>Hit@1＝0%；Hit@5＝100%</a:t>
+            </a:r>
+          </a:p>
+        </p:txBody>
+      </p:sp>
+      <p:sp>
+        <p:nvSpPr>
+          <p:cNvPr id="25" name="Rectangle 24"/>
+          <p:cNvSpPr/>
+          <p:nvPr/>
+        </p:nvSpPr>
+        <p:spPr>
+          <a:xfrm>
+            <a:off x="5638190" y="3721608"/>
+            <a:ext cx="5974689" cy="425196"/>
+          </a:xfrm>
+          <a:prstGeom prst="rect">
+            <a:avLst/>
+          </a:prstGeom>
+          <a:solidFill>
+            <a:srgbClr val="FFFFFF"/>
+          </a:solidFill>
+          <a:ln>
+            <a:noFill/>
+          </a:ln>
+        </p:spPr>
+        <p:style>
+          <a:lnRef idx="1">
+            <a:schemeClr val="accent1"/>
+          </a:lnRef>
+          <a:fillRef idx="3">
+            <a:schemeClr val="accent1"/>
+          </a:fillRef>
+          <a:effectRef idx="2">
+            <a:schemeClr val="accent1"/>
+          </a:effectRef>
+          <a:fontRef idx="minor">
+            <a:schemeClr val="lt1"/>
+          </a:fontRef>
+        </p:style>
+        <p:txBody>
+          <a:bodyPr rtlCol="0" anchor="ctr"/>
+          <a:lstStyle/>
+          <a:p>
+            <a:pPr algn="ctr"/>
+          </a:p>
+        </p:txBody>
+      </p:sp>
+      <p:sp>
+        <p:nvSpPr>
+          <p:cNvPr id="26" name="TextBox 25"/>
+          <p:cNvSpPr txBox="1"/>
+          <p:nvPr/>
+        </p:nvSpPr>
+        <p:spPr>
+          <a:xfrm>
+            <a:off x="5729630" y="3776472"/>
+            <a:ext cx="5791809" cy="333756"/>
+          </a:xfrm>
+          <a:prstGeom prst="rect">
+            <a:avLst/>
+          </a:prstGeom>
+          <a:noFill/>
+        </p:spPr>
+        <p:txBody>
+          <a:bodyPr wrap="square" lIns="13716" rIns="13716" tIns="9144" bIns="9144" anchor="ctr">
+            <a:spAutoFit/>
+          </a:bodyPr>
+          <a:lstStyle/>
+          <a:p>
+            <a:pPr algn="l">
+              <a:lnSpc>
+                <a:spcPct val="112000"/>
+              </a:lnSpc>
+              <a:spcBef>
+                <a:spcPts val="0"/>
+              </a:spcBef>
+              <a:spcAft>
+                <a:spcPts val="200"/>
+              </a:spcAft>
+            </a:pPr>
+            <a:r>
               <a:rPr sz="1700" b="0">
                 <a:solidFill>
                   <a:srgbClr val="183247"/>
@@ -15945,21 +16055,21 @@
                 <a:ea typeface="Noto Sans CJK TC"/>
                 <a:cs typeface="Noto Sans CJK TC"/>
               </a:rPr>
-              <a:t>另外提供、記錄來源的描述</a:t>
-            </a:r>
-          </a:p>
-        </p:txBody>
-      </p:sp>
-      <p:sp>
-        <p:nvSpPr>
-          <p:cNvPr id="22" name="Rectangle 21"/>
+              <a:t>這一題前五名至少有一個合適選項</a:t>
+            </a:r>
+          </a:p>
+        </p:txBody>
+      </p:sp>
+      <p:sp>
+        <p:nvSpPr>
+          <p:cNvPr id="27" name="Rectangle 26"/>
           <p:cNvSpPr/>
           <p:nvPr/>
         </p:nvSpPr>
         <p:spPr>
           <a:xfrm>
-            <a:off x="548640" y="2932176"/>
-            <a:ext cx="1712322" cy="664464"/>
+            <a:off x="548640" y="4146804"/>
+            <a:ext cx="5089550" cy="425196"/>
           </a:xfrm>
           <a:prstGeom prst="rect">
             <a:avLst/>
@@ -15995,14 +16105,14 @@
       </p:sp>
       <p:sp>
         <p:nvSpPr>
-          <p:cNvPr id="23" name="TextBox 22"/>
+          <p:cNvPr id="28" name="TextBox 27"/>
           <p:cNvSpPr txBox="1"/>
           <p:nvPr/>
         </p:nvSpPr>
         <p:spPr>
           <a:xfrm>
-            <a:off x="640080" y="2987040"/>
-            <a:ext cx="1529442" cy="573024"/>
+            <a:off x="640080" y="4201668"/>
+            <a:ext cx="4906670" cy="333756"/>
           </a:xfrm>
           <a:prstGeom prst="rect">
             <a:avLst/>
@@ -16035,21 +16145,21 @@
                 <a:ea typeface="Noto Sans CJK TC"/>
                 <a:cs typeface="Noto Sans CJK TC"/>
               </a:rPr>
-              <a:t>圖片 I</a:t>
-            </a:r>
-          </a:p>
-        </p:txBody>
-      </p:sp>
-      <p:sp>
-        <p:nvSpPr>
-          <p:cNvPr id="24" name="Rectangle 23"/>
+              <a:t>真正 Recall@5＝1/3＝33.3%</a:t>
+            </a:r>
+          </a:p>
+        </p:txBody>
+      </p:sp>
+      <p:sp>
+        <p:nvSpPr>
+          <p:cNvPr id="29" name="Rectangle 28"/>
           <p:cNvSpPr/>
           <p:nvPr/>
         </p:nvSpPr>
         <p:spPr>
           <a:xfrm>
-            <a:off x="2260962" y="2932176"/>
-            <a:ext cx="3292928" cy="664464"/>
+            <a:off x="5638190" y="4146804"/>
+            <a:ext cx="5974689" cy="425196"/>
           </a:xfrm>
           <a:prstGeom prst="rect">
             <a:avLst/>
@@ -16085,14 +16195,14 @@
       </p:sp>
       <p:sp>
         <p:nvSpPr>
-          <p:cNvPr id="25" name="TextBox 24"/>
+          <p:cNvPr id="30" name="TextBox 29"/>
           <p:cNvSpPr txBox="1"/>
           <p:nvPr/>
         </p:nvSpPr>
         <p:spPr>
           <a:xfrm>
-            <a:off x="2352402" y="2987040"/>
-            <a:ext cx="3110048" cy="573024"/>
+            <a:off x="5729630" y="4201668"/>
+            <a:ext cx="5791809" cy="333756"/>
           </a:xfrm>
           <a:prstGeom prst="rect">
             <a:avLst/>
@@ -16125,381 +16235,21 @@
                 <a:ea typeface="Noto Sans CJK TC"/>
                 <a:cs typeface="Noto Sans CJK TC"/>
               </a:rPr>
-              <a:t>全部視角的平均特徵</a:t>
-            </a:r>
-          </a:p>
-        </p:txBody>
-      </p:sp>
-      <p:sp>
-        <p:nvSpPr>
-          <p:cNvPr id="26" name="Rectangle 25"/>
+              <a:t>前五名找回全部可接受答案的三分之一</a:t>
+            </a:r>
+          </a:p>
+        </p:txBody>
+      </p:sp>
+      <p:sp>
+        <p:nvSpPr>
+          <p:cNvPr id="31" name="Rounded Rectangle 30"/>
           <p:cNvSpPr/>
           <p:nvPr/>
         </p:nvSpPr>
         <p:spPr>
           <a:xfrm>
-            <a:off x="5553891" y="2932176"/>
-            <a:ext cx="6058988" cy="664464"/>
-          </a:xfrm>
-          <a:prstGeom prst="rect">
-            <a:avLst/>
-          </a:prstGeom>
-          <a:solidFill>
-            <a:srgbClr val="EBF0F3"/>
-          </a:solidFill>
-          <a:ln>
-            <a:noFill/>
-          </a:ln>
-        </p:spPr>
-        <p:style>
-          <a:lnRef idx="1">
-            <a:schemeClr val="accent1"/>
-          </a:lnRef>
-          <a:fillRef idx="3">
-            <a:schemeClr val="accent1"/>
-          </a:fillRef>
-          <a:effectRef idx="2">
-            <a:schemeClr val="accent1"/>
-          </a:effectRef>
-          <a:fontRef idx="minor">
-            <a:schemeClr val="lt1"/>
-          </a:fontRef>
-        </p:style>
-        <p:txBody>
-          <a:bodyPr rtlCol="0" anchor="ctr"/>
-          <a:lstStyle/>
-          <a:p>
-            <a:pPr algn="ctr"/>
-          </a:p>
-        </p:txBody>
-      </p:sp>
-      <p:sp>
-        <p:nvSpPr>
-          <p:cNvPr id="27" name="TextBox 26"/>
-          <p:cNvSpPr txBox="1"/>
-          <p:nvPr/>
-        </p:nvSpPr>
-        <p:spPr>
-          <a:xfrm>
-            <a:off x="5645331" y="2987040"/>
-            <a:ext cx="5876108" cy="573024"/>
-          </a:xfrm>
-          <a:prstGeom prst="rect">
-            <a:avLst/>
-          </a:prstGeom>
-          <a:noFill/>
-        </p:spPr>
-        <p:txBody>
-          <a:bodyPr wrap="square" lIns="13716" rIns="13716" tIns="9144" bIns="9144" anchor="ctr">
-            <a:spAutoFit/>
-          </a:bodyPr>
-          <a:lstStyle/>
-          <a:p>
-            <a:pPr algn="l">
-              <a:lnSpc>
-                <a:spcPct val="112000"/>
-              </a:lnSpc>
-              <a:spcBef>
-                <a:spcPts val="0"/>
-              </a:spcBef>
-              <a:spcAft>
-                <a:spcPts val="200"/>
-              </a:spcAft>
-            </a:pPr>
-            <a:r>
-              <a:rPr sz="1700" b="0">
-                <a:solidFill>
-                  <a:srgbClr val="183247"/>
-                </a:solidFill>
-                <a:latin typeface="Noto Sans CJK TC"/>
-                <a:ea typeface="Noto Sans CJK TC"/>
-                <a:cs typeface="Noto Sans CJK TC"/>
-              </a:rPr>
-              <a:t>固定 1 個視角；候選排除此視角</a:t>
-            </a:r>
-          </a:p>
-        </p:txBody>
-      </p:sp>
-      <p:sp>
-        <p:nvSpPr>
-          <p:cNvPr id="28" name="Rectangle 27"/>
-          <p:cNvSpPr/>
-          <p:nvPr/>
-        </p:nvSpPr>
-        <p:spPr>
-          <a:xfrm>
-            <a:off x="548640" y="3596640"/>
-            <a:ext cx="1712322" cy="664464"/>
-          </a:xfrm>
-          <a:prstGeom prst="rect">
-            <a:avLst/>
-          </a:prstGeom>
-          <a:solidFill>
-            <a:srgbClr val="FFFFFF"/>
-          </a:solidFill>
-          <a:ln>
-            <a:noFill/>
-          </a:ln>
-        </p:spPr>
-        <p:style>
-          <a:lnRef idx="1">
-            <a:schemeClr val="accent1"/>
-          </a:lnRef>
-          <a:fillRef idx="3">
-            <a:schemeClr val="accent1"/>
-          </a:fillRef>
-          <a:effectRef idx="2">
-            <a:schemeClr val="accent1"/>
-          </a:effectRef>
-          <a:fontRef idx="minor">
-            <a:schemeClr val="lt1"/>
-          </a:fontRef>
-        </p:style>
-        <p:txBody>
-          <a:bodyPr rtlCol="0" anchor="ctr"/>
-          <a:lstStyle/>
-          <a:p>
-            <a:pPr algn="ctr"/>
-          </a:p>
-        </p:txBody>
-      </p:sp>
-      <p:sp>
-        <p:nvSpPr>
-          <p:cNvPr id="29" name="TextBox 28"/>
-          <p:cNvSpPr txBox="1"/>
-          <p:nvPr/>
-        </p:nvSpPr>
-        <p:spPr>
-          <a:xfrm>
-            <a:off x="640080" y="3651504"/>
-            <a:ext cx="1529442" cy="573024"/>
-          </a:xfrm>
-          <a:prstGeom prst="rect">
-            <a:avLst/>
-          </a:prstGeom>
-          <a:noFill/>
-        </p:spPr>
-        <p:txBody>
-          <a:bodyPr wrap="square" lIns="13716" rIns="13716" tIns="9144" bIns="9144" anchor="ctr">
-            <a:spAutoFit/>
-          </a:bodyPr>
-          <a:lstStyle/>
-          <a:p>
-            <a:pPr algn="l">
-              <a:lnSpc>
-                <a:spcPct val="112000"/>
-              </a:lnSpc>
-              <a:spcBef>
-                <a:spcPts val="0"/>
-              </a:spcBef>
-              <a:spcAft>
-                <a:spcPts val="200"/>
-              </a:spcAft>
-            </a:pPr>
-            <a:r>
-              <a:rPr sz="1700" b="1">
-                <a:solidFill>
-                  <a:srgbClr val="183247"/>
-                </a:solidFill>
-                <a:latin typeface="Noto Sans CJK TC"/>
-                <a:ea typeface="Noto Sans CJK TC"/>
-                <a:cs typeface="Noto Sans CJK TC"/>
-              </a:rPr>
-              <a:t>點雲 PC</a:t>
-            </a:r>
-          </a:p>
-        </p:txBody>
-      </p:sp>
-      <p:sp>
-        <p:nvSpPr>
-          <p:cNvPr id="30" name="Rectangle 29"/>
-          <p:cNvSpPr/>
-          <p:nvPr/>
-        </p:nvSpPr>
-        <p:spPr>
-          <a:xfrm>
-            <a:off x="2260962" y="3596640"/>
-            <a:ext cx="3292928" cy="664464"/>
-          </a:xfrm>
-          <a:prstGeom prst="rect">
-            <a:avLst/>
-          </a:prstGeom>
-          <a:solidFill>
-            <a:srgbClr val="FFFFFF"/>
-          </a:solidFill>
-          <a:ln>
-            <a:noFill/>
-          </a:ln>
-        </p:spPr>
-        <p:style>
-          <a:lnRef idx="1">
-            <a:schemeClr val="accent1"/>
-          </a:lnRef>
-          <a:fillRef idx="3">
-            <a:schemeClr val="accent1"/>
-          </a:fillRef>
-          <a:effectRef idx="2">
-            <a:schemeClr val="accent1"/>
-          </a:effectRef>
-          <a:fontRef idx="minor">
-            <a:schemeClr val="lt1"/>
-          </a:fontRef>
-        </p:style>
-        <p:txBody>
-          <a:bodyPr rtlCol="0" anchor="ctr"/>
-          <a:lstStyle/>
-          <a:p>
-            <a:pPr algn="ctr"/>
-          </a:p>
-        </p:txBody>
-      </p:sp>
-      <p:sp>
-        <p:nvSpPr>
-          <p:cNvPr id="31" name="TextBox 30"/>
-          <p:cNvSpPr txBox="1"/>
-          <p:nvPr/>
-        </p:nvSpPr>
-        <p:spPr>
-          <a:xfrm>
-            <a:off x="2352402" y="3651504"/>
-            <a:ext cx="3110048" cy="573024"/>
-          </a:xfrm>
-          <a:prstGeom prst="rect">
-            <a:avLst/>
-          </a:prstGeom>
-          <a:noFill/>
-        </p:spPr>
-        <p:txBody>
-          <a:bodyPr wrap="square" lIns="13716" rIns="13716" tIns="9144" bIns="9144" anchor="ctr">
-            <a:spAutoFit/>
-          </a:bodyPr>
-          <a:lstStyle/>
-          <a:p>
-            <a:pPr algn="l">
-              <a:lnSpc>
-                <a:spcPct val="112000"/>
-              </a:lnSpc>
-              <a:spcBef>
-                <a:spcPts val="0"/>
-              </a:spcBef>
-              <a:spcAft>
-                <a:spcPts val="200"/>
-              </a:spcAft>
-            </a:pPr>
-            <a:r>
-              <a:rPr sz="1700" b="0">
-                <a:solidFill>
-                  <a:srgbClr val="183247"/>
-                </a:solidFill>
-                <a:latin typeface="Noto Sans CJK TC"/>
-                <a:ea typeface="Noto Sans CJK TC"/>
-                <a:cs typeface="Noto Sans CJK TC"/>
-              </a:rPr>
-              <a:t>原有點雲</a:t>
-            </a:r>
-          </a:p>
-        </p:txBody>
-      </p:sp>
-      <p:sp>
-        <p:nvSpPr>
-          <p:cNvPr id="32" name="Rectangle 31"/>
-          <p:cNvSpPr/>
-          <p:nvPr/>
-        </p:nvSpPr>
-        <p:spPr>
-          <a:xfrm>
-            <a:off x="5553891" y="3596640"/>
-            <a:ext cx="6058988" cy="664464"/>
-          </a:xfrm>
-          <a:prstGeom prst="rect">
-            <a:avLst/>
-          </a:prstGeom>
-          <a:solidFill>
-            <a:srgbClr val="FFFFFF"/>
-          </a:solidFill>
-          <a:ln>
-            <a:noFill/>
-          </a:ln>
-        </p:spPr>
-        <p:style>
-          <a:lnRef idx="1">
-            <a:schemeClr val="accent1"/>
-          </a:lnRef>
-          <a:fillRef idx="3">
-            <a:schemeClr val="accent1"/>
-          </a:fillRef>
-          <a:effectRef idx="2">
-            <a:schemeClr val="accent1"/>
-          </a:effectRef>
-          <a:fontRef idx="minor">
-            <a:schemeClr val="lt1"/>
-          </a:fontRef>
-        </p:style>
-        <p:txBody>
-          <a:bodyPr rtlCol="0" anchor="ctr"/>
-          <a:lstStyle/>
-          <a:p>
-            <a:pPr algn="ctr"/>
-          </a:p>
-        </p:txBody>
-      </p:sp>
-      <p:sp>
-        <p:nvSpPr>
-          <p:cNvPr id="33" name="TextBox 32"/>
-          <p:cNvSpPr txBox="1"/>
-          <p:nvPr/>
-        </p:nvSpPr>
-        <p:spPr>
-          <a:xfrm>
-            <a:off x="5645331" y="3651504"/>
-            <a:ext cx="5876108" cy="573024"/>
-          </a:xfrm>
-          <a:prstGeom prst="rect">
-            <a:avLst/>
-          </a:prstGeom>
-          <a:noFill/>
-        </p:spPr>
-        <p:txBody>
-          <a:bodyPr wrap="square" lIns="13716" rIns="13716" tIns="9144" bIns="9144" anchor="ctr">
-            <a:spAutoFit/>
-          </a:bodyPr>
-          <a:lstStyle/>
-          <a:p>
-            <a:pPr algn="l">
-              <a:lnSpc>
-                <a:spcPct val="112000"/>
-              </a:lnSpc>
-              <a:spcBef>
-                <a:spcPts val="0"/>
-              </a:spcBef>
-              <a:spcAft>
-                <a:spcPts val="200"/>
-              </a:spcAft>
-            </a:pPr>
-            <a:r>
-              <a:rPr sz="1700" b="0">
-                <a:solidFill>
-                  <a:srgbClr val="183247"/>
-                </a:solidFill>
-                <a:latin typeface="Noto Sans CJK TC"/>
-                <a:ea typeface="Noto Sans CJK TC"/>
-                <a:cs typeface="Noto Sans CJK TC"/>
-              </a:rPr>
-              <a:t>同一網格重新取樣</a:t>
-            </a:r>
-          </a:p>
-        </p:txBody>
-      </p:sp>
-      <p:sp>
-        <p:nvSpPr>
-          <p:cNvPr id="34" name="Rounded Rectangle 33"/>
-          <p:cNvSpPr/>
-          <p:nvPr/>
-        </p:nvSpPr>
-        <p:spPr>
-          <a:xfrm>
-            <a:off x="548640" y="4553712"/>
-            <a:ext cx="5404104" cy="1078992"/>
+            <a:off x="548640" y="4809744"/>
+            <a:ext cx="5404104" cy="896112"/>
           </a:xfrm>
           <a:prstGeom prst="roundRect">
             <a:avLst>
@@ -16539,14 +16289,14 @@
       </p:sp>
       <p:sp>
         <p:nvSpPr>
-          <p:cNvPr id="35" name="TextBox 34"/>
+          <p:cNvPr id="32" name="TextBox 31"/>
           <p:cNvSpPr txBox="1"/>
           <p:nvPr/>
         </p:nvSpPr>
         <p:spPr>
           <a:xfrm>
-            <a:off x="713232" y="4690872"/>
-            <a:ext cx="5056632" cy="347472"/>
+            <a:off x="713232" y="4901184"/>
+            <a:ext cx="5056632" cy="310896"/>
           </a:xfrm>
           <a:prstGeom prst="rect">
             <a:avLst/>
@@ -16571,7 +16321,7 @@
               </a:spcAft>
             </a:pPr>
             <a:r>
-              <a:rPr sz="2100" b="1">
+              <a:rPr sz="2000" b="1">
                 <a:solidFill>
                   <a:srgbClr val="137D88"/>
                 </a:solidFill>
@@ -16579,21 +16329,21 @@
                 <a:ea typeface="Noto Sans CJK TC"/>
                 <a:cs typeface="Noto Sans CJK TC"/>
               </a:rPr>
-              <a:t>R@1：第一名就找對</a:t>
-            </a:r>
-          </a:p>
-        </p:txBody>
-      </p:sp>
-      <p:sp>
-        <p:nvSpPr>
-          <p:cNvPr id="36" name="TextBox 35"/>
+              <a:t>Hit：有沒有找到合適的</a:t>
+            </a:r>
+          </a:p>
+        </p:txBody>
+      </p:sp>
+      <p:sp>
+        <p:nvSpPr>
+          <p:cNvPr id="33" name="TextBox 32"/>
           <p:cNvSpPr txBox="1"/>
           <p:nvPr/>
         </p:nvSpPr>
         <p:spPr>
           <a:xfrm>
-            <a:off x="713232" y="5212080"/>
-            <a:ext cx="5056632" cy="283464"/>
+            <a:off x="713232" y="5385816"/>
+            <a:ext cx="5056632" cy="246888"/>
           </a:xfrm>
           <a:prstGeom prst="rect">
             <a:avLst/>
@@ -16618,7 +16368,7 @@
               </a:spcAft>
             </a:pPr>
             <a:r>
-              <a:rPr sz="1500" b="0">
+              <a:rPr sz="1400" b="0">
                 <a:solidFill>
                   <a:srgbClr val="657A88"/>
                 </a:solidFill>
@@ -16626,21 +16376,21 @@
                 <a:ea typeface="Noto Sans CJK TC"/>
                 <a:cs typeface="Noto Sans CJK TC"/>
               </a:rPr>
-              <a:t>像找商品編號：第一筆就是同一件資產</a:t>
-            </a:r>
-          </a:p>
-        </p:txBody>
-      </p:sp>
-      <p:sp>
-        <p:nvSpPr>
-          <p:cNvPr id="37" name="Rounded Rectangle 36"/>
+              <a:t>前五名只要有一個合適選項，就算命中。</a:t>
+            </a:r>
+          </a:p>
+        </p:txBody>
+      </p:sp>
+      <p:sp>
+        <p:nvSpPr>
+          <p:cNvPr id="34" name="Rounded Rectangle 33"/>
           <p:cNvSpPr/>
           <p:nvPr/>
         </p:nvSpPr>
         <p:spPr>
           <a:xfrm>
-            <a:off x="6208776" y="4553712"/>
-            <a:ext cx="5404104" cy="1078992"/>
+            <a:off x="6208776" y="4809744"/>
+            <a:ext cx="5404104" cy="896112"/>
           </a:xfrm>
           <a:prstGeom prst="roundRect">
             <a:avLst>
@@ -16680,14 +16430,14 @@
       </p:sp>
       <p:sp>
         <p:nvSpPr>
-          <p:cNvPr id="38" name="TextBox 37"/>
+          <p:cNvPr id="35" name="TextBox 34"/>
           <p:cNvSpPr txBox="1"/>
           <p:nvPr/>
         </p:nvSpPr>
         <p:spPr>
           <a:xfrm>
-            <a:off x="6373368" y="4690872"/>
-            <a:ext cx="5056632" cy="347472"/>
+            <a:off x="6373368" y="4901184"/>
+            <a:ext cx="5056632" cy="310896"/>
           </a:xfrm>
           <a:prstGeom prst="rect">
             <a:avLst/>
@@ -16712,7 +16462,7 @@
               </a:spcAft>
             </a:pPr>
             <a:r>
-              <a:rPr sz="2100" b="1">
+              <a:rPr sz="2000" b="1">
                 <a:solidFill>
                   <a:srgbClr val="137D88"/>
                 </a:solidFill>
@@ -16720,21 +16470,21 @@
                 <a:ea typeface="Noto Sans CJK TC"/>
                 <a:cs typeface="Noto Sans CJK TC"/>
               </a:rPr>
-              <a:t>R@5：前五名有找到</a:t>
-            </a:r>
-          </a:p>
-        </p:txBody>
-      </p:sp>
-      <p:sp>
-        <p:nvSpPr>
-          <p:cNvPr id="39" name="TextBox 38"/>
+              <a:t>Recall：合適的找回多少</a:t>
+            </a:r>
+          </a:p>
+        </p:txBody>
+      </p:sp>
+      <p:sp>
+        <p:nvSpPr>
+          <p:cNvPr id="36" name="TextBox 35"/>
           <p:cNvSpPr txBox="1"/>
           <p:nvPr/>
         </p:nvSpPr>
         <p:spPr>
           <a:xfrm>
-            <a:off x="6373368" y="5212080"/>
-            <a:ext cx="5056632" cy="283464"/>
+            <a:off x="6373368" y="5385816"/>
+            <a:ext cx="5056632" cy="246888"/>
           </a:xfrm>
           <a:prstGeom prst="rect">
             <a:avLst/>
@@ -16759,7 +16509,7 @@
               </a:spcAft>
             </a:pPr>
             <a:r>
-              <a:rPr sz="1500" b="0">
+              <a:rPr sz="1400" b="0">
                 <a:solidFill>
                   <a:srgbClr val="657A88"/>
                 </a:solidFill>
@@ -16767,7 +16517,7 @@
                 <a:ea typeface="Noto Sans CJK TC"/>
                 <a:cs typeface="Noto Sans CJK TC"/>
               </a:rPr>
-              <a:t>看前五筆裡，是否包含同一件資產</a:t>
+              <a:t>有三個合適選項，找到一個＝找回三分之一。</a:t>
             </a:r>
           </a:p>
         </p:txBody>
@@ -16930,7 +16680,7 @@
                 <a:ea typeface="Noto Sans CJK TC"/>
                 <a:cs typeface="Noto Sans CJK TC"/>
               </a:rPr>
-              <a:t>和論文可能不同、尚不確定的地方</a:t>
+              <a:t>新主評估與論文、舊診斷分開看</a:t>
             </a:r>
           </a:p>
         </p:txBody>
@@ -17055,7 +16805,7 @@
                 <a:ea typeface="Noto Sans CJK TC"/>
                 <a:cs typeface="Noto Sans CJK TC"/>
               </a:rPr>
-              <a:t>可比較的部分沿用；作者未公開的細節，保留未知並揭露差異。</a:t>
+              <a:t>這是已批准的本地需求檢索評估；不冒充作者 Table 1 原始協定。</a:t>
             </a:r>
           </a:p>
         </p:txBody>
@@ -17102,7 +16852,7 @@
                 <a:ea typeface="Noto Sans CJK TC"/>
                 <a:cs typeface="Noto Sans CJK TC"/>
               </a:rPr>
-              <a:t>來源：論文 Table 1、目前自訂評估規格與程式｜完整依據見備忘稿</a:t>
+              <a:t>來源：論文 Table 1 與本地需求檢索規格；正式評估尚待執行｜完整依據見備忘稿</a:t>
             </a:r>
           </a:p>
         </p:txBody>
@@ -17329,7 +17079,7 @@
                 <a:ea typeface="Noto Sans CJK TC"/>
                 <a:cs typeface="Noto Sans CJK TC"/>
               </a:rPr>
-              <a:t>論文確定內容</a:t>
+              <a:t>論文或舊診斷</a:t>
             </a:r>
           </a:p>
         </p:txBody>
@@ -17419,7 +17169,7 @@
                 <a:ea typeface="Noto Sans CJK TC"/>
                 <a:cs typeface="Noto Sans CJK TC"/>
               </a:rPr>
-              <a:t>本地做法／尚待釐清</a:t>
+              <a:t>新主評估</a:t>
             </a:r>
           </a:p>
         </p:txBody>
@@ -17509,7 +17259,7 @@
                 <a:ea typeface="Noto Sans CJK TC"/>
                 <a:cs typeface="Noto Sans CJK TC"/>
               </a:rPr>
-              <a:t>模態與指標</a:t>
+              <a:t>問題與正解</a:t>
             </a:r>
           </a:p>
         </p:txBody>
@@ -17599,7 +17349,7 @@
                 <a:ea typeface="Noto Sans CJK TC"/>
                 <a:cs typeface="Noto Sans CJK TC"/>
               </a:rPr>
-              <a:t>七種模態；R@1、R@5</a:t>
+              <a:t>論文完整 query／正解配對未公開</a:t>
             </a:r>
           </a:p>
         </p:txBody>
@@ -17689,7 +17439,7 @@
                 <a:ea typeface="Noto Sans CJK TC"/>
                 <a:cs typeface="Noto Sans CJK TC"/>
               </a:rPr>
-              <a:t>沿用這些比較項目</a:t>
+              <a:t>使用者需求；每條件多個可接受候選</a:t>
             </a:r>
           </a:p>
         </p:txBody>
@@ -17779,7 +17529,7 @@
                 <a:ea typeface="Noto Sans CJK TC"/>
                 <a:cs typeface="Noto Sans CJK TC"/>
               </a:rPr>
-              <a:t>查詢如何形成</a:t>
+              <a:t>主要指標</a:t>
             </a:r>
           </a:p>
         </p:txBody>
@@ -17869,7 +17619,7 @@
                 <a:ea typeface="Noto Sans CJK TC"/>
                 <a:cs typeface="Noto Sans CJK TC"/>
               </a:rPr>
-              <a:t>只明說部分配對情形</a:t>
+              <a:t>論文稱 R@1／R@5；完整標註規則未知</a:t>
             </a:r>
           </a:p>
         </p:txBody>
@@ -17959,7 +17709,7 @@
                 <a:ea typeface="Noto Sans CJK TC"/>
                 <a:cs typeface="Noto Sans CJK TC"/>
               </a:rPr>
-              <a:t>完整 query 規則未知；兩觀測為本地設計</a:t>
+              <a:t>Hit@1／Hit@5；輔助真正 Recall@k</a:t>
             </a:r>
           </a:p>
         </p:txBody>
@@ -18049,7 +17799,7 @@
                 <a:ea typeface="Noto Sans CJK TC"/>
                 <a:cs typeface="Noto Sans CJK TC"/>
               </a:rPr>
-              <a:t>候選池</a:t>
+              <a:t>P-only baseline</a:t>
             </a:r>
           </a:p>
         </p:txBody>
@@ -18139,7 +17889,7 @@
                 <a:ea typeface="Noto Sans CJK TC"/>
                 <a:cs typeface="Noto Sans CJK TC"/>
               </a:rPr>
-              <a:t>Objaverse-LVIS 約 48K 資產</a:t>
+              <a:t>論文說 query／gallery 使用相同 PC embedding</a:t>
             </a:r>
           </a:p>
         </p:txBody>
@@ -18229,7 +17979,7 @@
                 <a:ea typeface="Noto Sans CJK TC"/>
                 <a:cs typeface="Noto Sans CJK TC"/>
               </a:rPr>
-              <a:t>確切 gallery UID 名單與數量可能不同</a:t>
+              <a:t>本地 query=P；gallery 固定融合 T+I+P</a:t>
             </a:r>
           </a:p>
         </p:txBody>
@@ -18319,7 +18069,7 @@
                 <a:ea typeface="Noto Sans CJK TC"/>
                 <a:cs typeface="Noto Sans CJK TC"/>
               </a:rPr>
-              <a:t>編碼器訓練</a:t>
+              <a:t>候選與資料</a:t>
             </a:r>
           </a:p>
         </p:txBody>
@@ -18409,7 +18159,7 @@
                 <a:ea typeface="Noto Sans CJK TC"/>
                 <a:cs typeface="Noto Sans CJK TC"/>
               </a:rPr>
-              <a:t>描述 Stage 1 兩塔訓練</a:t>
+              <a:t>論文約 48K；確切候選清單未公開</a:t>
             </a:r>
           </a:p>
         </p:txBody>
@@ -18499,7 +18249,7 @@
                 <a:ea typeface="Noto Sans CJK TC"/>
                 <a:cs typeface="Noto Sans CJK TC"/>
               </a:rPr>
-              <a:t>實際 CLIP 凍結；尚未完全對齊</a:t>
+              <a:t>先固定審核完整的候選池與題目分母</a:t>
             </a:r>
           </a:p>
         </p:txBody>
@@ -18589,7 +18339,7 @@
                 <a:ea typeface="Noto Sans CJK TC"/>
                 <a:cs typeface="Noto Sans CJK TC"/>
               </a:rPr>
-              <a:t>選模與評估</a:t>
+              <a:t>既有四十二組</a:t>
             </a:r>
           </a:p>
         </p:txBody>
@@ -18679,7 +18429,7 @@
                 <a:ea typeface="Noto Sans CJK TC"/>
                 <a:cs typeface="Noto Sans CJK TC"/>
               </a:rPr>
-              <a:t>描述訓練／測試切分</a:t>
+              <a:t>同一資產 UID 的兩觀測辨識診斷</a:t>
             </a:r>
           </a:p>
         </p:txBody>
@@ -18769,7 +18519,7 @@
                 <a:ea typeface="Noto Sans CJK TC"/>
                 <a:cs typeface="Noto Sans CJK TC"/>
               </a:rPr>
-              <a:t>現行選模與部分評估重疊，必須揭露</a:t>
+              <a:t>另列診斷；不是新主評估</a:t>
             </a:r>
           </a:p>
         </p:txBody>
@@ -18932,7 +18682,7 @@
                 <a:ea typeface="Noto Sans CJK TC"/>
                 <a:cs typeface="Noto Sans CJK TC"/>
               </a:rPr>
-              <a:t>正式跑分前，先固定題目與規則</a:t>
+              <a:t>先寫題、審答案、封存，最後才跑模型</a:t>
             </a:r>
           </a:p>
         </p:txBody>
@@ -19057,7 +18807,7 @@
                 <a:ea typeface="Noto Sans CJK TC"/>
                 <a:cs typeface="Noto Sans CJK TC"/>
               </a:rPr>
-              <a:t>先固定輸入、模型和正解，再跑分；看完結果不換題目。</a:t>
+              <a:t>每題、每個模態條件，都先審完固定候選池；未審完就是待完成。</a:t>
             </a:r>
           </a:p>
         </p:txBody>
@@ -19104,7 +18854,7 @@
                 <a:ea typeface="Noto Sans CJK TC"/>
                 <a:cs typeface="Noto Sans CJK TC"/>
               </a:rPr>
-              <a:t>來源：論文 Table 1、目前自訂評估規格與程式｜完整依據見備忘稿</a:t>
+              <a:t>來源：論文 Table 1 與本地需求檢索規格；正式評估尚待執行｜完整依據見備忘稿</a:t>
             </a:r>
           </a:p>
         </p:txBody>
@@ -19292,7 +19042,7 @@
                 <a:ea typeface="Noto Sans CJK TC"/>
                 <a:cs typeface="Noto Sans CJK TC"/>
               </a:rPr>
-              <a:t>固定查詢題目</a:t>
+              <a:t>準備需求與參考</a:t>
             </a:r>
           </a:p>
         </p:txBody>
@@ -19339,7 +19089,7 @@
                 <a:ea typeface="Noto Sans CJK TC"/>
                 <a:cs typeface="Noto Sans CJK TC"/>
               </a:rPr>
-              <a:t>鎖定物件清單</a:t>
+              <a:t>ULIP-2 描述可作草稿</a:t>
             </a:r>
           </a:p>
           <a:p>
@@ -19363,7 +19113,7 @@
                 <a:ea typeface="Noto Sans CJK TC"/>
                 <a:cs typeface="Noto Sans CJK TC"/>
               </a:rPr>
-              <a:t>準備第二份文字描述</a:t>
+              <a:t>記錄原始文字、照片與點雲</a:t>
             </a:r>
           </a:p>
         </p:txBody>
@@ -19504,7 +19254,7 @@
                 <a:ea typeface="Noto Sans CJK TC"/>
                 <a:cs typeface="Noto Sans CJK TC"/>
               </a:rPr>
-              <a:t>固定模型版本</a:t>
+              <a:t>先審核合適答案</a:t>
             </a:r>
           </a:p>
         </p:txBody>
@@ -19551,7 +19301,7 @@
                 <a:ea typeface="Noto Sans CJK TC"/>
                 <a:cs typeface="Noto Sans CJK TC"/>
               </a:rPr>
-              <a:t>指定兩階段模型存檔</a:t>
+              <a:t>逐條件審完全部候選</a:t>
             </a:r>
           </a:p>
           <a:p>
@@ -19575,7 +19325,7 @@
                 <a:ea typeface="Noto Sans CJK TC"/>
                 <a:cs typeface="Noto Sans CJK TC"/>
               </a:rPr>
-              <a:t>保留版本與來源</a:t>
+              <a:t>來源 UID 不自動當正解</a:t>
             </a:r>
           </a:p>
         </p:txBody>
@@ -19716,7 +19466,7 @@
                 <a:ea typeface="Noto Sans CJK TC"/>
                 <a:cs typeface="Noto Sans CJK TC"/>
               </a:rPr>
-              <a:t>固定候選與正解</a:t>
+              <a:t>凍結資料與模型</a:t>
             </a:r>
           </a:p>
         </p:txBody>
@@ -19763,7 +19513,7 @@
                 <a:ea typeface="Noto Sans CJK TC"/>
                 <a:cs typeface="Noto Sans CJK TC"/>
               </a:rPr>
-              <a:t>共用候選物件庫</a:t>
+              <a:t>固定題目、答案與候選池</a:t>
             </a:r>
           </a:p>
           <a:p>
@@ -19787,7 +19537,7 @@
                 <a:ea typeface="Noto Sans CJK TC"/>
                 <a:cs typeface="Noto Sans CJK TC"/>
               </a:rPr>
-              <a:t>以同一資產編號為正解</a:t>
+              <a:t>核對 Stage 1／2 版本</a:t>
             </a:r>
           </a:p>
         </p:txBody>
@@ -19928,7 +19678,7 @@
                 <a:ea typeface="Noto Sans CJK TC"/>
                 <a:cs typeface="Noto Sans CJK TC"/>
               </a:rPr>
-              <a:t>保留逐題紀錄</a:t>
+              <a:t>記錄逐題結果</a:t>
             </a:r>
           </a:p>
         </p:txBody>
@@ -19975,7 +19725,7 @@
                 <a:ea typeface="Noto Sans CJK TC"/>
                 <a:cs typeface="Noto Sans CJK TC"/>
               </a:rPr>
-              <a:t>留下排名、缺漏與錯誤</a:t>
+              <a:t>主報 Hit，另報 Recall</a:t>
             </a:r>
           </a:p>
           <a:p>
@@ -19999,7 +19749,7 @@
                 <a:ea typeface="Noto Sans CJK TC"/>
                 <a:cs typeface="Noto Sans CJK TC"/>
               </a:rPr>
-              <a:t>正式跑分尚待執行</a:t>
+              <a:t>未審完的資料不跑正式分數</a:t>
             </a:r>
           </a:p>
         </p:txBody>
@@ -20046,7 +19796,7 @@
                 <a:ea typeface="Noto Sans CJK TC"/>
                 <a:cs typeface="Noto Sans CJK TC"/>
               </a:rPr>
-              <a:t>先前小型驗證只檢查流程能否運作；正式結果仍待這一輪資料完成。</a:t>
+              <a:t>先完成並封存審核，再看模型排名；缺少標籤不能直接算不相關。</a:t>
             </a:r>
           </a:p>
         </p:txBody>

</xml_diff>